<commit_message>
feat: Scout & Sell demo page — mobile UI for Natchez walk-ins
/admin/scout — dark theme, single-thumb UX for outdoor readability.
Enter business name + URL → cascading reveal:
1. Brand DNA (colors, voice, aesthetic flavor)
2. 3-post social campaign
3. Radio spot script
4. Reputation Guardian (review response drafts)

All powered by the 6 marketing API routes already on main.
Chase's demo tool for tomorrow's Natchez walk-ins.

Co-Authored-By: Claude Opus 4.6 (1M context) <noreply@anthropic.com>
</commit_message>
<xml_diff>
--- a/docs/pitches/Natchez-Tourism-Playbook.pptx
+++ b/docs/pitches/Natchez-Tourism-Playbook.pptx
@@ -1545,7 +1545,7 @@
             <a:r>
               <a:rPr lang="en-US" sz="1100" spc="600" kern="0" dirty="0">
                 <a:solidFill>
-                  <a:srgbClr val="B8A99A"/>
+                  <a:srgbClr val="D4C8BA"/>
                 </a:solidFill>
                 <a:latin typeface="Georgia" pitchFamily="34" charset="0"/>
                 <a:ea typeface="Georgia" pitchFamily="34" charset="-122"/>
@@ -1682,7 +1682,7 @@
             <a:r>
               <a:rPr lang="en-US" sz="1600" dirty="0">
                 <a:solidFill>
-                  <a:srgbClr val="B8A99A"/>
+                  <a:srgbClr val="D4C8BA"/>
                 </a:solidFill>
                 <a:latin typeface="Calibri" pitchFamily="34" charset="0"/>
                 <a:ea typeface="Calibri" pitchFamily="34" charset="-122"/>
@@ -1696,13 +1696,126 @@
       </p:sp>
       <p:sp>
         <p:nvSpPr>
-          <p:cNvPr id="8" name="Text 6"/>
-          <p:cNvSpPr/>
-          <p:nvPr/>
-        </p:nvSpPr>
-        <p:spPr>
-          <a:xfrm>
-            <a:off x="731520" y="4572000"/>
+          <p:cNvPr id="8" name="Shape 6"/>
+          <p:cNvSpPr/>
+          <p:nvPr/>
+        </p:nvSpPr>
+        <p:spPr>
+          <a:xfrm>
+            <a:off x="6858000" y="1371600"/>
+            <a:ext cx="1828800" cy="2560320"/>
+          </a:xfrm>
+          <a:prstGeom prst="rect">
+            <a:avLst/>
+          </a:prstGeom>
+          <a:solidFill>
+            <a:srgbClr val="2C2520"/>
+          </a:solidFill>
+          <a:ln/>
+        </p:spPr>
+      </p:sp>
+      <p:sp>
+        <p:nvSpPr>
+          <p:cNvPr id="9" name="Shape 7"/>
+          <p:cNvSpPr/>
+          <p:nvPr/>
+        </p:nvSpPr>
+        <p:spPr>
+          <a:xfrm>
+            <a:off x="6858000" y="1371600"/>
+            <a:ext cx="1828800" cy="54864"/>
+          </a:xfrm>
+          <a:prstGeom prst="rect">
+            <a:avLst/>
+          </a:prstGeom>
+          <a:solidFill>
+            <a:srgbClr val="C4713B"/>
+          </a:solidFill>
+          <a:ln/>
+        </p:spPr>
+      </p:sp>
+      <p:sp>
+        <p:nvSpPr>
+          <p:cNvPr id="10" name="Text 8"/>
+          <p:cNvSpPr/>
+          <p:nvPr/>
+        </p:nvSpPr>
+        <p:spPr>
+          <a:xfrm>
+            <a:off x="6858000" y="1645920"/>
+            <a:ext cx="1828800" cy="2011680"/>
+          </a:xfrm>
+          <a:prstGeom prst="rect">
+            <a:avLst/>
+          </a:prstGeom>
+          <a:noFill/>
+          <a:ln/>
+        </p:spPr>
+        <p:txBody>
+          <a:bodyPr wrap="square" lIns="0" tIns="0" rIns="0" bIns="0" rtlCol="0" anchor="ctr"/>
+          <a:lstStyle/>
+          <a:p>
+            <a:pPr algn="ctr" indent="0" marL="0">
+              <a:buNone/>
+            </a:pPr>
+            <a:r>
+              <a:rPr lang="en-US" sz="2000" dirty="0">
+                <a:solidFill>
+                  <a:srgbClr val="D4C8BA"/>
+                </a:solidFill>
+                <a:latin typeface="Georgia" pitchFamily="34" charset="0"/>
+                <a:ea typeface="Georgia" pitchFamily="34" charset="-122"/>
+                <a:cs typeface="Georgia" pitchFamily="34" charset="-120"/>
+              </a:rPr>
+              <a:t>700K</a:t>
+            </a:r>
+            <a:endParaRPr lang="en-US" sz="2000" dirty="0"/>
+          </a:p>
+          <a:p>
+            <a:pPr algn="ctr" indent="0" marL="0">
+              <a:buNone/>
+            </a:pPr>
+            <a:r>
+              <a:rPr lang="en-US" sz="2000" dirty="0">
+                <a:solidFill>
+                  <a:srgbClr val="D4C8BA"/>
+                </a:solidFill>
+                <a:latin typeface="Georgia" pitchFamily="34" charset="0"/>
+                <a:ea typeface="Georgia" pitchFamily="34" charset="-122"/>
+                <a:cs typeface="Georgia" pitchFamily="34" charset="-120"/>
+              </a:rPr>
+              <a:t>visitors</a:t>
+            </a:r>
+            <a:endParaRPr lang="en-US" sz="2000" dirty="0"/>
+          </a:p>
+          <a:p>
+            <a:pPr algn="ctr" indent="0" marL="0">
+              <a:buNone/>
+            </a:pPr>
+            <a:r>
+              <a:rPr lang="en-US" sz="2000" dirty="0">
+                <a:solidFill>
+                  <a:srgbClr val="D4C8BA"/>
+                </a:solidFill>
+                <a:latin typeface="Georgia" pitchFamily="34" charset="0"/>
+                <a:ea typeface="Georgia" pitchFamily="34" charset="-122"/>
+                <a:cs typeface="Georgia" pitchFamily="34" charset="-120"/>
+              </a:rPr>
+              <a:t>annually</a:t>
+            </a:r>
+            <a:endParaRPr lang="en-US" sz="2000" dirty="0"/>
+          </a:p>
+        </p:txBody>
+      </p:sp>
+      <p:sp>
+        <p:nvSpPr>
+          <p:cNvPr id="11" name="Text 9"/>
+          <p:cNvSpPr/>
+          <p:nvPr/>
+        </p:nvSpPr>
+        <p:spPr>
+          <a:xfrm>
+            <a:off x="731520" y="4480560"/>
             <a:ext cx="7315200" cy="274320"/>
           </a:xfrm>
           <a:prstGeom prst="rect">
@@ -1719,9 +1832,9 @@
               <a:buNone/>
             </a:pPr>
             <a:r>
-              <a:rPr lang="en-US" sz="1000" dirty="0">
-                <a:solidFill>
-                  <a:srgbClr val="B8A99A"/>
+              <a:rPr lang="en-US" sz="1100" dirty="0">
+                <a:solidFill>
+                  <a:srgbClr val="D4C8BA"/>
                 </a:solidFill>
                 <a:latin typeface="Calibri" pitchFamily="34" charset="0"/>
                 <a:ea typeface="Calibri" pitchFamily="34" charset="-122"/>
@@ -1729,7 +1842,7 @@
               </a:rPr>
               <a:t>Presented by Hillbilly Dreams Inc.  ·  Natchez, Mississippi</a:t>
             </a:r>
-            <a:endParaRPr lang="en-US" sz="1000" dirty="0"/>
+            <a:endParaRPr lang="en-US" sz="1100" dirty="0"/>
           </a:p>
         </p:txBody>
       </p:sp>
@@ -1812,7 +1925,7 @@
             <a:r>
               <a:rPr lang="en-US" sz="1100" spc="500" kern="0" dirty="0">
                 <a:solidFill>
-                  <a:srgbClr val="B8A99A"/>
+                  <a:srgbClr val="D4C8BA"/>
                 </a:solidFill>
                 <a:latin typeface="Georgia" pitchFamily="34" charset="0"/>
                 <a:ea typeface="Georgia" pitchFamily="34" charset="-122"/>
@@ -1956,7 +2069,7 @@
             <a:r>
               <a:rPr lang="en-US" sz="1400" dirty="0">
                 <a:solidFill>
-                  <a:srgbClr val="B8A99A"/>
+                  <a:srgbClr val="D4C8BA"/>
                 </a:solidFill>
                 <a:latin typeface="Calibri" pitchFamily="34" charset="0"/>
                 <a:ea typeface="Calibri" pitchFamily="34" charset="-122"/>
@@ -2264,7 +2377,7 @@
             <a:r>
               <a:rPr lang="en-US" sz="900" i="1" dirty="0">
                 <a:solidFill>
-                  <a:srgbClr val="B8A99A"/>
+                  <a:srgbClr val="D4C8BA"/>
                 </a:solidFill>
                 <a:latin typeface="Calibri" pitchFamily="34" charset="0"/>
                 <a:ea typeface="Calibri" pitchFamily="34" charset="-122"/>
@@ -2355,7 +2468,7 @@
             <a:r>
               <a:rPr lang="en-US" sz="1100" spc="500" kern="0" dirty="0">
                 <a:solidFill>
-                  <a:srgbClr val="B8A99A"/>
+                  <a:srgbClr val="D4C8BA"/>
                 </a:solidFill>
                 <a:latin typeface="Georgia" pitchFamily="34" charset="0"/>
                 <a:ea typeface="Georgia" pitchFamily="34" charset="-122"/>
@@ -2582,7 +2695,7 @@
             <a:r>
               <a:rPr lang="en-US" sz="1200" dirty="0">
                 <a:solidFill>
-                  <a:srgbClr val="B8A99A"/>
+                  <a:srgbClr val="D4C8BA"/>
                 </a:solidFill>
                 <a:latin typeface="Calibri" pitchFamily="34" charset="0"/>
                 <a:ea typeface="Calibri" pitchFamily="34" charset="-122"/>
@@ -2770,7 +2883,7 @@
             <a:r>
               <a:rPr lang="en-US" sz="1200" dirty="0">
                 <a:solidFill>
-                  <a:srgbClr val="B8A99A"/>
+                  <a:srgbClr val="D4C8BA"/>
                 </a:solidFill>
                 <a:latin typeface="Calibri" pitchFamily="34" charset="0"/>
                 <a:ea typeface="Calibri" pitchFamily="34" charset="-122"/>
@@ -2958,7 +3071,7 @@
             <a:r>
               <a:rPr lang="en-US" sz="1200" dirty="0">
                 <a:solidFill>
-                  <a:srgbClr val="B8A99A"/>
+                  <a:srgbClr val="D4C8BA"/>
                 </a:solidFill>
                 <a:latin typeface="Calibri" pitchFamily="34" charset="0"/>
                 <a:ea typeface="Calibri" pitchFamily="34" charset="-122"/>
@@ -3049,7 +3162,7 @@
             <a:r>
               <a:rPr lang="en-US" sz="1100" spc="500" kern="0" dirty="0">
                 <a:solidFill>
-                  <a:srgbClr val="B8A99A"/>
+                  <a:srgbClr val="D4C8BA"/>
                 </a:solidFill>
                 <a:latin typeface="Georgia" pitchFamily="34" charset="0"/>
                 <a:ea typeface="Georgia" pitchFamily="34" charset="-122"/>
@@ -3127,7 +3240,7 @@
             <a:r>
               <a:rPr lang="en-US" sz="1400" i="1" dirty="0">
                 <a:solidFill>
-                  <a:srgbClr val="B8A99A"/>
+                  <a:srgbClr val="D4C8BA"/>
                 </a:solidFill>
                 <a:latin typeface="Calibri" pitchFamily="34" charset="0"/>
                 <a:ea typeface="Calibri" pitchFamily="34" charset="-122"/>
@@ -3256,7 +3369,7 @@
             <a:r>
               <a:rPr lang="en-US" sz="1200" dirty="0">
                 <a:solidFill>
-                  <a:srgbClr val="B8A99A"/>
+                  <a:srgbClr val="D4C8BA"/>
                 </a:solidFill>
                 <a:latin typeface="Calibri" pitchFamily="34" charset="0"/>
                 <a:ea typeface="Calibri" pitchFamily="34" charset="-122"/>
@@ -3385,7 +3498,7 @@
             <a:r>
               <a:rPr lang="en-US" sz="1200" dirty="0">
                 <a:solidFill>
-                  <a:srgbClr val="B8A99A"/>
+                  <a:srgbClr val="D4C8BA"/>
                 </a:solidFill>
                 <a:latin typeface="Calibri" pitchFamily="34" charset="0"/>
                 <a:ea typeface="Calibri" pitchFamily="34" charset="-122"/>
@@ -3514,7 +3627,7 @@
             <a:r>
               <a:rPr lang="en-US" sz="1200" dirty="0">
                 <a:solidFill>
-                  <a:srgbClr val="B8A99A"/>
+                  <a:srgbClr val="D4C8BA"/>
                 </a:solidFill>
                 <a:latin typeface="Calibri" pitchFamily="34" charset="0"/>
                 <a:ea typeface="Calibri" pitchFamily="34" charset="-122"/>
@@ -3605,7 +3718,7 @@
             <a:r>
               <a:rPr lang="en-US" sz="1100" spc="500" kern="0" dirty="0">
                 <a:solidFill>
-                  <a:srgbClr val="B8A99A"/>
+                  <a:srgbClr val="D4C8BA"/>
                 </a:solidFill>
                 <a:latin typeface="Georgia" pitchFamily="34" charset="0"/>
                 <a:ea typeface="Georgia" pitchFamily="34" charset="-122"/>
@@ -3793,7 +3906,7 @@
             <a:r>
               <a:rPr lang="en-US" sz="1200" dirty="0">
                 <a:solidFill>
-                  <a:srgbClr val="B8A99A"/>
+                  <a:srgbClr val="D4C8BA"/>
                 </a:solidFill>
                 <a:latin typeface="Calibri" pitchFamily="34" charset="0"/>
                 <a:ea typeface="Calibri" pitchFamily="34" charset="-122"/>
@@ -3942,7 +4055,7 @@
             <a:r>
               <a:rPr lang="en-US" sz="1200" dirty="0">
                 <a:solidFill>
-                  <a:srgbClr val="B8A99A"/>
+                  <a:srgbClr val="D4C8BA"/>
                 </a:solidFill>
                 <a:latin typeface="Calibri" pitchFamily="34" charset="0"/>
                 <a:ea typeface="Calibri" pitchFamily="34" charset="-122"/>
@@ -4112,7 +4225,7 @@
             <a:r>
               <a:rPr lang="en-US" sz="1100" spc="500" kern="0" dirty="0">
                 <a:solidFill>
-                  <a:srgbClr val="B8A99A"/>
+                  <a:srgbClr val="D4C8BA"/>
                 </a:solidFill>
                 <a:latin typeface="Georgia" pitchFamily="34" charset="0"/>
                 <a:ea typeface="Georgia" pitchFamily="34" charset="-122"/>
@@ -4190,7 +4303,7 @@
             <a:r>
               <a:rPr lang="en-US" sz="1500" i="1" dirty="0">
                 <a:solidFill>
-                  <a:srgbClr val="B8A99A"/>
+                  <a:srgbClr val="D4C8BA"/>
                 </a:solidFill>
                 <a:latin typeface="Calibri" pitchFamily="34" charset="0"/>
                 <a:ea typeface="Calibri" pitchFamily="34" charset="-122"/>
@@ -4244,7 +4357,7 @@
             <a:avLst/>
           </a:prstGeom>
           <a:solidFill>
-            <a:srgbClr val="C4713B"/>
+            <a:srgbClr val="D4A849"/>
           </a:solidFill>
           <a:ln/>
         </p:spPr>
@@ -4276,7 +4389,7 @@
             <a:r>
               <a:rPr lang="en-US" sz="3600" b="1" dirty="0">
                 <a:solidFill>
-                  <a:srgbClr val="C4713B"/>
+                  <a:srgbClr val="D4A849"/>
                 </a:solidFill>
                 <a:latin typeface="Georgia" pitchFamily="34" charset="0"/>
                 <a:ea typeface="Georgia" pitchFamily="34" charset="-122"/>
@@ -4335,7 +4448,7 @@
         </p:nvSpPr>
         <p:spPr>
           <a:xfrm>
-            <a:off x="2194560" y="2651760"/>
+            <a:off x="2194560" y="2743200"/>
             <a:ext cx="228600" cy="457200"/>
           </a:xfrm>
           <a:prstGeom prst="rect">
@@ -4352,14 +4465,14 @@
               <a:buNone/>
             </a:pPr>
             <a:r>
-              <a:rPr lang="en-US" sz="2000" dirty="0">
-                <a:solidFill>
-                  <a:srgbClr val="B8A99A"/>
-                </a:solidFill>
-              </a:rPr>
-              <a:t>→</a:t>
-            </a:r>
-            <a:endParaRPr lang="en-US" sz="2000" dirty="0"/>
+              <a:rPr lang="en-US" sz="1400" dirty="0">
+                <a:solidFill>
+                  <a:srgbClr val="C4713B"/>
+                </a:solidFill>
+              </a:rPr>
+              <a:t>▶</a:t>
+            </a:r>
+            <a:endParaRPr lang="en-US" sz="1400" dirty="0"/>
           </a:p>
         </p:txBody>
       </p:sp>
@@ -4405,7 +4518,7 @@
             <a:avLst/>
           </a:prstGeom>
           <a:solidFill>
-            <a:srgbClr val="D4915F"/>
+            <a:srgbClr val="D4A849"/>
           </a:solidFill>
           <a:ln/>
         </p:spPr>
@@ -4437,7 +4550,7 @@
             <a:r>
               <a:rPr lang="en-US" sz="3600" b="1" dirty="0">
                 <a:solidFill>
-                  <a:srgbClr val="D4915F"/>
+                  <a:srgbClr val="D4A849"/>
                 </a:solidFill>
                 <a:latin typeface="Georgia" pitchFamily="34" charset="0"/>
                 <a:ea typeface="Georgia" pitchFamily="34" charset="-122"/>
@@ -4496,7 +4609,7 @@
         </p:nvSpPr>
         <p:spPr>
           <a:xfrm>
-            <a:off x="3886200" y="2651760"/>
+            <a:off x="3886200" y="2743200"/>
             <a:ext cx="228600" cy="457200"/>
           </a:xfrm>
           <a:prstGeom prst="rect">
@@ -4513,14 +4626,14 @@
               <a:buNone/>
             </a:pPr>
             <a:r>
-              <a:rPr lang="en-US" sz="2000" dirty="0">
-                <a:solidFill>
-                  <a:srgbClr val="B8A99A"/>
-                </a:solidFill>
-              </a:rPr>
-              <a:t>→</a:t>
-            </a:r>
-            <a:endParaRPr lang="en-US" sz="2000" dirty="0"/>
+              <a:rPr lang="en-US" sz="1400" dirty="0">
+                <a:solidFill>
+                  <a:srgbClr val="C4713B"/>
+                </a:solidFill>
+              </a:rPr>
+              <a:t>▶</a:t>
+            </a:r>
+            <a:endParaRPr lang="en-US" sz="1400" dirty="0"/>
           </a:p>
         </p:txBody>
       </p:sp>
@@ -4657,7 +4770,7 @@
         </p:nvSpPr>
         <p:spPr>
           <a:xfrm>
-            <a:off x="5577840" y="2651760"/>
+            <a:off x="5577840" y="2743200"/>
             <a:ext cx="228600" cy="457200"/>
           </a:xfrm>
           <a:prstGeom prst="rect">
@@ -4674,14 +4787,14 @@
               <a:buNone/>
             </a:pPr>
             <a:r>
-              <a:rPr lang="en-US" sz="2000" dirty="0">
-                <a:solidFill>
-                  <a:srgbClr val="B8A99A"/>
-                </a:solidFill>
-              </a:rPr>
-              <a:t>→</a:t>
-            </a:r>
-            <a:endParaRPr lang="en-US" sz="2000" dirty="0"/>
+              <a:rPr lang="en-US" sz="1400" dirty="0">
+                <a:solidFill>
+                  <a:srgbClr val="C4713B"/>
+                </a:solidFill>
+              </a:rPr>
+              <a:t>▶</a:t>
+            </a:r>
+            <a:endParaRPr lang="en-US" sz="1400" dirty="0"/>
           </a:p>
         </p:txBody>
       </p:sp>
@@ -4727,7 +4840,7 @@
             <a:avLst/>
           </a:prstGeom>
           <a:solidFill>
-            <a:srgbClr val="C4713B"/>
+            <a:srgbClr val="D4A849"/>
           </a:solidFill>
           <a:ln/>
         </p:spPr>
@@ -4759,7 +4872,7 @@
             <a:r>
               <a:rPr lang="en-US" sz="3600" b="1" dirty="0">
                 <a:solidFill>
-                  <a:srgbClr val="C4713B"/>
+                  <a:srgbClr val="D4A849"/>
                 </a:solidFill>
                 <a:latin typeface="Georgia" pitchFamily="34" charset="0"/>
                 <a:ea typeface="Georgia" pitchFamily="34" charset="-122"/>
@@ -4818,7 +4931,7 @@
         </p:nvSpPr>
         <p:spPr>
           <a:xfrm>
-            <a:off x="7269480" y="2651760"/>
+            <a:off x="7269480" y="2743200"/>
             <a:ext cx="228600" cy="457200"/>
           </a:xfrm>
           <a:prstGeom prst="rect">
@@ -4835,14 +4948,14 @@
               <a:buNone/>
             </a:pPr>
             <a:r>
-              <a:rPr lang="en-US" sz="2000" dirty="0">
-                <a:solidFill>
-                  <a:srgbClr val="B8A99A"/>
-                </a:solidFill>
-              </a:rPr>
-              <a:t>→</a:t>
-            </a:r>
-            <a:endParaRPr lang="en-US" sz="2000" dirty="0"/>
+              <a:rPr lang="en-US" sz="1400" dirty="0">
+                <a:solidFill>
+                  <a:srgbClr val="C4713B"/>
+                </a:solidFill>
+              </a:rPr>
+              <a:t>▶</a:t>
+            </a:r>
+            <a:endParaRPr lang="en-US" sz="1400" dirty="0"/>
           </a:p>
         </p:txBody>
       </p:sp>
@@ -5129,7 +5242,7 @@
             <a:r>
               <a:rPr lang="en-US" sz="1100" spc="500" kern="0" dirty="0">
                 <a:solidFill>
-                  <a:srgbClr val="B8A99A"/>
+                  <a:srgbClr val="D4C8BA"/>
                 </a:solidFill>
                 <a:latin typeface="Georgia" pitchFamily="34" charset="0"/>
                 <a:ea typeface="Georgia" pitchFamily="34" charset="-122"/>
@@ -5897,7 +6010,7 @@
             <a:r>
               <a:rPr lang="en-US" sz="1100" spc="500" kern="0" dirty="0">
                 <a:solidFill>
-                  <a:srgbClr val="B8A99A"/>
+                  <a:srgbClr val="D4C8BA"/>
                 </a:solidFill>
                 <a:latin typeface="Georgia" pitchFamily="34" charset="0"/>
                 <a:ea typeface="Georgia" pitchFamily="34" charset="-122"/>
@@ -6274,20 +6387,20 @@
         </p:nvSpPr>
         <p:spPr>
           <a:xfrm>
-            <a:off x="731520" y="4434840"/>
-            <a:ext cx="7680960" cy="274320"/>
-          </a:xfrm>
-          <a:prstGeom prst="rect">
-            <a:avLst/>
-          </a:prstGeom>
-          <a:noFill/>
-          <a:ln/>
-        </p:spPr>
-        <p:txBody>
-          <a:bodyPr wrap="square" lIns="0" tIns="0" rIns="0" bIns="0" rtlCol="0" anchor="ctr"/>
-          <a:lstStyle/>
-          <a:p>
-            <a:pPr algn="ctr" indent="0" marL="0">
+            <a:off x="1097280" y="4434840"/>
+            <a:ext cx="6949440" cy="274320"/>
+          </a:xfrm>
+          <a:prstGeom prst="rect">
+            <a:avLst/>
+          </a:prstGeom>
+          <a:noFill/>
+          <a:ln/>
+        </p:spPr>
+        <p:txBody>
+          <a:bodyPr wrap="square" lIns="0" tIns="0" rIns="0" bIns="0" rtlCol="0" anchor="ctr"/>
+          <a:lstStyle/>
+          <a:p>
+            <a:pPr algn="l" indent="0" marL="0">
               <a:buNone/>
             </a:pPr>
             <a:r>
@@ -6313,20 +6426,20 @@
         </p:nvSpPr>
         <p:spPr>
           <a:xfrm>
-            <a:off x="731520" y="4754880"/>
-            <a:ext cx="7680960" cy="274320"/>
-          </a:xfrm>
-          <a:prstGeom prst="rect">
-            <a:avLst/>
-          </a:prstGeom>
-          <a:noFill/>
-          <a:ln/>
-        </p:spPr>
-        <p:txBody>
-          <a:bodyPr wrap="square" lIns="0" tIns="0" rIns="0" bIns="0" rtlCol="0" anchor="ctr"/>
-          <a:lstStyle/>
-          <a:p>
-            <a:pPr algn="ctr" indent="0" marL="0">
+            <a:off x="1097280" y="4754880"/>
+            <a:ext cx="6949440" cy="274320"/>
+          </a:xfrm>
+          <a:prstGeom prst="rect">
+            <a:avLst/>
+          </a:prstGeom>
+          <a:noFill/>
+          <a:ln/>
+        </p:spPr>
+        <p:txBody>
+          <a:bodyPr wrap="square" lIns="0" tIns="0" rIns="0" bIns="0" rtlCol="0" anchor="ctr"/>
+          <a:lstStyle/>
+          <a:p>
+            <a:pPr algn="l" indent="0" marL="0">
               <a:buNone/>
             </a:pPr>
             <a:r>
@@ -6338,7 +6451,7 @@
                 <a:ea typeface="Calibri" pitchFamily="34" charset="-122"/>
                 <a:cs typeface="Calibri" pitchFamily="34" charset="-120"/>
               </a:rPr>
-              <a:t>hillbillydreamsinc.com</a:t>
+              <a:t>hillbillydreamsinc.com  ·  chase@hillbillydreamsinc.com</a:t>
             </a:r>
             <a:endParaRPr lang="en-US" sz="1200" dirty="0"/>
           </a:p>

</xml_diff>

<commit_message>
feat: photo-first Scout — snap a sign, get the whole DSD engine
- New /api/marketing/scout-photo — Gemini Vision reads business
  signs/cards, extracts name, runs full analysis in one call
- New /api/marketing/scout — text fallback, name + city only
- Scout UI: camera capture button, photo preview, cascading results
- Branded as Deep South Directory (not "road manager")
- No auth on scout APIs — field demo tool

Co-Authored-By: Claude Opus 4.6 (1M context) <noreply@anthropic.com>
</commit_message>
<xml_diff>
--- a/docs/pitches/Natchez-Tourism-Playbook.pptx
+++ b/docs/pitches/Natchez-Tourism-Playbook.pptx
@@ -3594,7 +3594,7 @@
                 <a:ea typeface="Georgia" pitchFamily="34" charset="-122"/>
                 <a:cs typeface="Georgia" pitchFamily="34" charset="-120"/>
               </a:rPr>
-              <a:t>Photography Library</a:t>
+              <a:t>Content Strategy</a:t>
             </a:r>
             <a:endParaRPr lang="en-US" sz="1600" dirty="0"/>
           </a:p>
@@ -3633,7 +3633,7 @@
                 <a:ea typeface="Calibri" pitchFamily="34" charset="-122"/>
                 <a:cs typeface="Calibri" pitchFamily="34" charset="-120"/>
               </a:rPr>
-              <a:t>600+ high-end images of the corridor ready for your use. Professional, editorial quality.</a:t>
+              <a:t>We fill the void. Editorial photography, video, and written content across every channel — building the presence that makes Natchez visible.</a:t>
             </a:r>
             <a:endParaRPr lang="en-US" sz="1200" dirty="0"/>
           </a:p>
@@ -5780,7 +5780,7 @@
                 <a:ea typeface="Calibri" pitchFamily="34" charset="-122"/>
                 <a:cs typeface="Calibri" pitchFamily="34" charset="-120"/>
               </a:rPr>
-              <a:t>Photography Library — 600+ corridor images licensed for city/tourism use</a:t>
+              <a:t>Content Production — editorial photography, video, and written content filling the void across every channel</a:t>
             </a:r>
             <a:endParaRPr lang="en-US" sz="1300" dirty="0"/>
           </a:p>
@@ -5866,7 +5866,7 @@
                 <a:ea typeface="Calibri" pitchFamily="34" charset="-122"/>
                 <a:cs typeface="Calibri" pitchFamily="34" charset="-120"/>
               </a:rPr>
-              <a:t>AI Search Optimization — ensure Natchez businesses appear in ChatGPT, Google AI, Perplexity</a:t>
+              <a:t>AI + SEO Equity — every piece of content builds search visibility, AI visibility, and social presence simultaneously</a:t>
             </a:r>
             <a:endParaRPr lang="en-US" sz="1300" dirty="0"/>
           </a:p>

</xml_diff>